<commit_message>
Weekly Report 3 Added
</commit_message>
<xml_diff>
--- a/Presentations/MidSem_Presentation_Image_Processing_Grp11.pptx
+++ b/Presentations/MidSem_Presentation_Image_Processing_Grp11.pptx
@@ -268,8 +268,11 @@
     </a:lvl9pPr>
   </p:defaultTextStyle>
   <p:extLst>
+    <p:ext uri="{EFAFB233-063F-42B5-8137-9DF3F51BA10A}">
+      <p15:sldGuideLst xmlns:p15="http://schemas.microsoft.com/office/powerpoint/2012/main"/>
+    </p:ext>
     <p:ext uri="GoogleSlidesCustomDataVersion2">
-      <go:slidesCustomData xmlns:go="http://customooxmlschemas.google.com/" xmlns:ahyp="http://schemas.microsoft.com/office/drawing/2018/hyperlinkcolor" xmlns:p15="http://schemas.microsoft.com/office/powerpoint/2012/main" xmlns:p14="http://schemas.microsoft.com/office/powerpoint/2010/main" xmlns:com="http://schemas.openxmlformats.org/drawingml/2006/compatibility" xmlns:pvml="urn:schemas-microsoft-com:office:powerpoint" xmlns:v="urn:schemas-microsoft-com:vml" xmlns:o="urn:schemas-microsoft-com:office:office" xmlns:dgm="http://schemas.openxmlformats.org/drawingml/2006/diagram" xmlns:c="http://schemas.openxmlformats.org/drawingml/2006/chart" xmlns:mv="urn:schemas-microsoft-com:mac:vml" xmlns:mc="http://schemas.openxmlformats.org/markup-compatibility/2006" xmlns="" r:id="rId24" roundtripDataSignature="AMtx7mh2gV7qhYHhqIbG7xHsFedTikJ+GQ=="/>
+      <go:slidesCustomData xmlns="" xmlns:mc="http://schemas.openxmlformats.org/markup-compatibility/2006" xmlns:mv="urn:schemas-microsoft-com:mac:vml" xmlns:c="http://schemas.openxmlformats.org/drawingml/2006/chart" xmlns:dgm="http://schemas.openxmlformats.org/drawingml/2006/diagram" xmlns:o="urn:schemas-microsoft-com:office:office" xmlns:v="urn:schemas-microsoft-com:vml" xmlns:pvml="urn:schemas-microsoft-com:office:powerpoint" xmlns:com="http://schemas.openxmlformats.org/drawingml/2006/compatibility" xmlns:p14="http://schemas.microsoft.com/office/powerpoint/2010/main" xmlns:p15="http://schemas.microsoft.com/office/powerpoint/2012/main" xmlns:ahyp="http://schemas.microsoft.com/office/drawing/2018/hyperlinkcolor" xmlns:go="http://customooxmlschemas.google.com/" r:id="rId24" roundtripDataSignature="AMtx7mh2gV7qhYHhqIbG7xHsFedTikJ+GQ=="/>
     </p:ext>
   </p:extLst>
 </p:presentation>
@@ -14907,7 +14910,7 @@
         </p:spPr>
         <p:txBody>
           <a:bodyPr spcFirstLastPara="1" wrap="square" lIns="91425" tIns="45700" rIns="91425" bIns="45700" anchor="t" anchorCtr="0">
-            <a:normAutofit lnSpcReduction="10000"/>
+            <a:normAutofit/>
           </a:bodyPr>
           <a:lstStyle/>
           <a:p>
@@ -14929,7 +14932,7 @@
               <a:buChar char="•"/>
             </a:pPr>
             <a:r>
-              <a:rPr lang="en-US" sz="2200" b="1">
+              <a:rPr lang="en-US" sz="2200" b="1" dirty="0">
                 <a:latin typeface="Helvetica Neue"/>
                 <a:ea typeface="Helvetica Neue"/>
                 <a:cs typeface="Helvetica Neue"/>
@@ -14938,10 +14941,10 @@
               <a:t>Visual Hull :</a:t>
             </a:r>
             <a:r>
-              <a:rPr lang="en-US" sz="2200"/>
+              <a:rPr lang="en-US" sz="2200" dirty="0"/>
               <a:t> Implementing the 3D reconstruction algorithm by carving a voxel grid using the generated silhouettes.</a:t>
             </a:r>
-            <a:endParaRPr sz="2200"/>
+            <a:endParaRPr sz="2200" dirty="0"/>
           </a:p>
           <a:p>
             <a:pPr marL="228600" lvl="0" indent="-215900" algn="l" rtl="0">
@@ -14958,7 +14961,7 @@
               <a:buChar char="•"/>
             </a:pPr>
             <a:r>
-              <a:rPr lang="en-US" sz="2200" b="1">
+              <a:rPr lang="en-US" sz="2200" b="1" dirty="0">
                 <a:latin typeface="Helvetica Neue"/>
                 <a:ea typeface="Helvetica Neue"/>
                 <a:cs typeface="Helvetica Neue"/>
@@ -14967,10 +14970,10 @@
               <a:t>Sphere Carving </a:t>
             </a:r>
             <a:r>
-              <a:rPr lang="en-US" sz="2200"/>
+              <a:rPr lang="en-US" sz="2200" dirty="0"/>
               <a:t>: Validating the concept of visual hull through a simulation.</a:t>
             </a:r>
-            <a:endParaRPr sz="2200"/>
+            <a:endParaRPr sz="2200" dirty="0"/>
           </a:p>
           <a:p>
             <a:pPr marL="228600" lvl="0" indent="-215900" algn="l" rtl="0">
@@ -14987,7 +14990,7 @@
               <a:buChar char="•"/>
             </a:pPr>
             <a:r>
-              <a:rPr lang="en-US" sz="2200" b="1">
+              <a:rPr lang="en-US" sz="2200" b="1" dirty="0">
                 <a:latin typeface="Helvetica Neue"/>
                 <a:ea typeface="Helvetica Neue"/>
                 <a:cs typeface="Helvetica Neue"/>
@@ -14996,10 +14999,10 @@
               <a:t>Resolution Testing:</a:t>
             </a:r>
             <a:r>
-              <a:rPr lang="en-US" sz="2200"/>
+              <a:rPr lang="en-US" sz="2200" dirty="0"/>
               <a:t> Using different grid densities to analyze the output.</a:t>
             </a:r>
-            <a:endParaRPr sz="2200"/>
+            <a:endParaRPr sz="2200" dirty="0"/>
           </a:p>
           <a:p>
             <a:pPr marL="228600" lvl="0" indent="-215900" algn="l" rtl="0">
@@ -15017,7 +15020,7 @@
               <a:buChar char="•"/>
             </a:pPr>
             <a:r>
-              <a:rPr lang="en-US" sz="2200" b="1">
+              <a:rPr lang="en-US" sz="2200" b="1" dirty="0">
                 <a:latin typeface="Helvetica Neue"/>
                 <a:ea typeface="Helvetica Neue"/>
                 <a:cs typeface="Helvetica Neue"/>
@@ -15026,11 +15029,11 @@
               <a:t>Autonomous Threshold: </a:t>
             </a:r>
             <a:r>
-              <a:rPr lang="en-US" sz="2200"/>
+              <a:rPr lang="en-US" sz="2200" dirty="0"/>
               <a:t>Replacing the manual thresholding in the binarization step with an automated algorithm.</a:t>
             </a:r>
             <a:r>
-              <a:rPr lang="en-US" sz="2200" b="1">
+              <a:rPr lang="en-US" sz="2200" b="1" dirty="0">
                 <a:latin typeface="Helvetica Neue"/>
                 <a:ea typeface="Helvetica Neue"/>
                 <a:cs typeface="Helvetica Neue"/>
@@ -15038,7 +15041,7 @@
               </a:rPr>
               <a:t> </a:t>
             </a:r>
-            <a:endParaRPr sz="2200" b="1">
+            <a:endParaRPr sz="2200" b="1" dirty="0">
               <a:latin typeface="Helvetica Neue"/>
               <a:ea typeface="Helvetica Neue"/>
               <a:cs typeface="Helvetica Neue"/>
@@ -15061,7 +15064,7 @@
               <a:buChar char="•"/>
             </a:pPr>
             <a:r>
-              <a:rPr lang="en-US" sz="2200" b="1">
+              <a:rPr lang="en-US" sz="2200" b="1" dirty="0">
                 <a:latin typeface="Helvetica Neue"/>
                 <a:ea typeface="Helvetica Neue"/>
                 <a:cs typeface="Helvetica Neue"/>
@@ -15070,10 +15073,10 @@
               <a:t>Interactive Web UI Dashboard: </a:t>
             </a:r>
             <a:r>
-              <a:rPr lang="en-US" sz="2200"/>
+              <a:rPr lang="en-US" sz="2200" dirty="0"/>
               <a:t>Developing a web-interface for uploading images of the diamond and the final 3-D images generated.</a:t>
             </a:r>
-            <a:endParaRPr sz="2200"/>
+            <a:endParaRPr sz="2200" dirty="0"/>
           </a:p>
           <a:p>
             <a:pPr marL="914400" lvl="0" indent="0" algn="l" rtl="0">
@@ -15088,7 +15091,7 @@
               </a:spcAft>
               <a:buNone/>
             </a:pPr>
-            <a:endParaRPr sz="2200"/>
+            <a:endParaRPr sz="2200" dirty="0"/>
           </a:p>
           <a:p>
             <a:pPr marL="228600" lvl="0" indent="-76200" algn="l" rtl="0">
@@ -15108,7 +15111,7 @@
               <a:buFont typeface="Helvetica Neue Light"/>
               <a:buNone/>
             </a:pPr>
-            <a:endParaRPr sz="2200"/>
+            <a:endParaRPr sz="2200" dirty="0"/>
           </a:p>
           <a:p>
             <a:pPr marL="228600" lvl="0" indent="-76200" algn="l" rtl="0">
@@ -15128,7 +15131,7 @@
               <a:buFont typeface="Helvetica Neue Light"/>
               <a:buNone/>
             </a:pPr>
-            <a:endParaRPr sz="2200"/>
+            <a:endParaRPr sz="2200" dirty="0"/>
           </a:p>
         </p:txBody>
       </p:sp>
@@ -15362,11 +15365,11 @@
               <a:buNone/>
             </a:pPr>
             <a:r>
-              <a:rPr lang="en-US" sz="1900"/>
+              <a:rPr lang="en-US" sz="1900" dirty="0"/>
               <a:t>[1] Regular 3D voxel grid—unoccupied. </a:t>
             </a:r>
             <a:r>
-              <a:rPr lang="en-US" sz="1900" u="sng">
+              <a:rPr lang="en-US" sz="1900" u="sng" dirty="0">
                 <a:solidFill>
                   <a:schemeClr val="hlink"/>
                 </a:solidFill>
@@ -15374,7 +15377,7 @@
               </a:rPr>
               <a:t>https://www.researchgate.net/publication/324389722/figure/fig3/AS:11431281391286952@1745321870314/Regular-3D-voxel-grid-unoccupied.tif</a:t>
             </a:r>
-            <a:endParaRPr sz="1900"/>
+            <a:endParaRPr sz="1900" dirty="0"/>
           </a:p>
           <a:p>
             <a:pPr marL="0" lvl="0" indent="0" algn="l" rtl="0">
@@ -15389,7 +15392,7 @@
               </a:spcAft>
               <a:buNone/>
             </a:pPr>
-            <a:endParaRPr sz="1900"/>
+            <a:endParaRPr sz="1900" dirty="0"/>
           </a:p>
           <a:p>
             <a:pPr marL="0" lvl="0" indent="0" algn="l" rtl="0">
@@ -15405,11 +15408,11 @@
               <a:buNone/>
             </a:pPr>
             <a:r>
-              <a:rPr lang="en-US" sz="1900"/>
+              <a:rPr lang="en-US" sz="1900" dirty="0"/>
               <a:t>[2] 2D to 3D image conversion algorithms. (n.d.-a). </a:t>
             </a:r>
             <a:r>
-              <a:rPr lang="en-US" sz="1900" u="sng">
+              <a:rPr lang="en-US" sz="1900" u="sng" dirty="0">
                 <a:solidFill>
                   <a:schemeClr val="hlink"/>
                 </a:solidFill>
@@ -15417,7 +15420,7 @@
               </a:rPr>
               <a:t>https://www.itm-conferences.org/articles/itmconf/pdf/2024/07/itmconf_icacs2024_01010.pdf</a:t>
             </a:r>
-            <a:endParaRPr sz="1900"/>
+            <a:endParaRPr sz="1900" dirty="0"/>
           </a:p>
           <a:p>
             <a:pPr marL="0" lvl="0" indent="0" algn="l" rtl="0">
@@ -15433,10 +15436,10 @@
               <a:buNone/>
             </a:pPr>
             <a:r>
-              <a:rPr lang="en-US" sz="1900"/>
+              <a:rPr lang="en-US" sz="1900" dirty="0"/>
               <a:t> </a:t>
             </a:r>
-            <a:endParaRPr sz="1900"/>
+            <a:endParaRPr sz="1900" dirty="0"/>
           </a:p>
           <a:p>
             <a:pPr marL="0" lvl="0" indent="0" algn="l" rtl="0">
@@ -15451,7 +15454,7 @@
               </a:spcAft>
               <a:buNone/>
             </a:pPr>
-            <a:endParaRPr sz="1900"/>
+            <a:endParaRPr sz="1900" dirty="0"/>
           </a:p>
           <a:p>
             <a:pPr marL="0" lvl="0" indent="0" algn="l" rtl="0">
@@ -15466,7 +15469,7 @@
               </a:spcAft>
               <a:buNone/>
             </a:pPr>
-            <a:endParaRPr sz="1900"/>
+            <a:endParaRPr sz="1900" dirty="0"/>
           </a:p>
           <a:p>
             <a:pPr marL="914400" lvl="0" indent="0" algn="l" rtl="0">
@@ -15481,7 +15484,7 @@
               </a:spcAft>
               <a:buNone/>
             </a:pPr>
-            <a:endParaRPr sz="1900"/>
+            <a:endParaRPr sz="1900" dirty="0"/>
           </a:p>
           <a:p>
             <a:pPr marL="228600" lvl="0" indent="-76200" algn="l" rtl="0">
@@ -15501,7 +15504,7 @@
               <a:buFont typeface="Helvetica Neue Light"/>
               <a:buNone/>
             </a:pPr>
-            <a:endParaRPr sz="1900"/>
+            <a:endParaRPr sz="1900" dirty="0"/>
           </a:p>
           <a:p>
             <a:pPr marL="228600" lvl="0" indent="-76200" algn="l" rtl="0">
@@ -15521,7 +15524,7 @@
               <a:buFont typeface="Helvetica Neue Light"/>
               <a:buNone/>
             </a:pPr>
-            <a:endParaRPr sz="1900"/>
+            <a:endParaRPr sz="1900" dirty="0"/>
           </a:p>
         </p:txBody>
       </p:sp>
@@ -15738,7 +15741,7 @@
         </p:spPr>
         <p:txBody>
           <a:bodyPr spcFirstLastPara="1" wrap="square" lIns="91425" tIns="45700" rIns="91425" bIns="45700" anchor="t" anchorCtr="0">
-            <a:normAutofit fontScale="92500" lnSpcReduction="20000"/>
+            <a:normAutofit/>
           </a:bodyPr>
           <a:lstStyle/>
           <a:p>
@@ -15756,13 +15759,13 @@
               <a:buChar char="•"/>
             </a:pPr>
             <a:r>
-              <a:rPr lang="en-US"/>
+              <a:rPr lang="en-US" dirty="0"/>
               <a:t>Realistic 3D model generation from 2D images</a:t>
             </a:r>
             <a:br>
-              <a:rPr lang="en-US"/>
+              <a:rPr lang="en-US" dirty="0"/>
             </a:br>
-            <a:endParaRPr/>
+            <a:endParaRPr dirty="0"/>
           </a:p>
           <a:p>
             <a:pPr marL="457200" lvl="0" indent="-369570" algn="l" rtl="0">
@@ -15779,13 +15782,13 @@
               <a:buChar char="•"/>
             </a:pPr>
             <a:r>
-              <a:rPr lang="en-US"/>
+              <a:rPr lang="en-US" dirty="0"/>
               <a:t>Motivation: Diamonds’ precision geometry requires accurate 3D visualization</a:t>
             </a:r>
             <a:br>
-              <a:rPr lang="en-US"/>
+              <a:rPr lang="en-US" dirty="0"/>
             </a:br>
-            <a:endParaRPr/>
+            <a:endParaRPr dirty="0"/>
           </a:p>
           <a:p>
             <a:pPr marL="457200" lvl="0" indent="-369570" algn="l" rtl="0">
@@ -15802,13 +15805,13 @@
               <a:buChar char="•"/>
             </a:pPr>
             <a:r>
-              <a:rPr lang="en-US"/>
+              <a:rPr lang="en-US" dirty="0"/>
               <a:t>Aim: To reconstruct a 3D diamond stone model using multiple 2D silhouette projections</a:t>
             </a:r>
             <a:br>
-              <a:rPr lang="en-US"/>
+              <a:rPr lang="en-US" dirty="0"/>
             </a:br>
-            <a:endParaRPr/>
+            <a:endParaRPr dirty="0"/>
           </a:p>
           <a:p>
             <a:pPr marL="457200" lvl="0" indent="-369570" algn="l" rtl="0">
@@ -15825,10 +15828,10 @@
               <a:buChar char="•"/>
             </a:pPr>
             <a:r>
-              <a:rPr lang="en-US"/>
+              <a:rPr lang="en-US" dirty="0"/>
               <a:t>Applications: 3D modeling, virtual visualization, Reconciling for laser cutting</a:t>
             </a:r>
-            <a:endParaRPr/>
+            <a:endParaRPr dirty="0"/>
           </a:p>
           <a:p>
             <a:pPr marL="457200" lvl="0" indent="0" algn="l" rtl="0">
@@ -15843,7 +15846,7 @@
               </a:spcAft>
               <a:buNone/>
             </a:pPr>
-            <a:endParaRPr/>
+            <a:endParaRPr dirty="0"/>
           </a:p>
           <a:p>
             <a:pPr marL="914400" lvl="0" indent="0" algn="l" rtl="0">
@@ -15858,7 +15861,7 @@
               </a:spcAft>
               <a:buNone/>
             </a:pPr>
-            <a:endParaRPr/>
+            <a:endParaRPr dirty="0"/>
           </a:p>
           <a:p>
             <a:pPr marL="228600" lvl="0" indent="-76200" algn="l" rtl="0">
@@ -15878,7 +15881,7 @@
               <a:buFont typeface="Helvetica Neue Light"/>
               <a:buNone/>
             </a:pPr>
-            <a:endParaRPr/>
+            <a:endParaRPr dirty="0"/>
           </a:p>
           <a:p>
             <a:pPr marL="228600" lvl="0" indent="-76200" algn="l" rtl="0">
@@ -15898,7 +15901,7 @@
               <a:buFont typeface="Helvetica Neue Light"/>
               <a:buNone/>
             </a:pPr>
-            <a:endParaRPr/>
+            <a:endParaRPr dirty="0"/>
           </a:p>
         </p:txBody>
       </p:sp>
@@ -16026,8 +16029,8 @@
         </p:blipFill>
         <p:spPr>
           <a:xfrm>
-            <a:off x="4987707" y="4073885"/>
-            <a:ext cx="2215700" cy="2215700"/>
+            <a:off x="7924800" y="5160370"/>
+            <a:ext cx="1350463" cy="1399989"/>
           </a:xfrm>
           <a:prstGeom prst="rect">
             <a:avLst/>
@@ -16053,8 +16056,8 @@
         </p:blipFill>
         <p:spPr>
           <a:xfrm>
-            <a:off x="2272808" y="4052520"/>
-            <a:ext cx="2427492" cy="2215701"/>
+            <a:off x="6113978" y="5302984"/>
+            <a:ext cx="1462978" cy="1227904"/>
           </a:xfrm>
           <a:prstGeom prst="rect">
             <a:avLst/>
@@ -16081,8 +16084,8 @@
         </p:blipFill>
         <p:spPr>
           <a:xfrm>
-            <a:off x="7408500" y="4180708"/>
-            <a:ext cx="3483248" cy="1959325"/>
+            <a:off x="8860453" y="575403"/>
+            <a:ext cx="2493325" cy="1305692"/>
           </a:xfrm>
           <a:prstGeom prst="rect">
             <a:avLst/>
@@ -16101,8 +16104,8 @@
         </p:nvSpPr>
         <p:spPr>
           <a:xfrm>
-            <a:off x="2272800" y="6289125"/>
-            <a:ext cx="10891800" cy="471000"/>
+            <a:off x="1696602" y="6282597"/>
+            <a:ext cx="10891800" cy="1000244"/>
           </a:xfrm>
           <a:prstGeom prst="rect">
             <a:avLst/>
@@ -16131,7 +16134,7 @@
               <a:buNone/>
             </a:pPr>
             <a:r>
-              <a:rPr lang="en-US" sz="400" b="1">
+              <a:rPr lang="en-US" sz="1000" b="1" dirty="0">
                 <a:solidFill>
                   <a:schemeClr val="dk1"/>
                 </a:solidFill>
@@ -16139,7 +16142,7 @@
               <a:t>Free3D</a:t>
             </a:r>
             <a:r>
-              <a:rPr lang="en-US" sz="400">
+              <a:rPr lang="en-US" sz="1000" dirty="0">
                 <a:solidFill>
                   <a:schemeClr val="dk1"/>
                 </a:solidFill>
@@ -16147,7 +16150,7 @@
               <a:t>. (n.d.). </a:t>
             </a:r>
             <a:r>
-              <a:rPr lang="en-US" sz="400" i="1">
+              <a:rPr lang="en-US" sz="1000" i="1" dirty="0">
                 <a:solidFill>
                   <a:schemeClr val="dk1"/>
                 </a:solidFill>
@@ -16155,7 +16158,7 @@
               <a:t>Diamond 3D model</a:t>
             </a:r>
             <a:r>
-              <a:rPr lang="en-US" sz="400">
+              <a:rPr lang="en-US" sz="1000" dirty="0">
                 <a:solidFill>
                   <a:schemeClr val="dk1"/>
                 </a:solidFill>
@@ -16163,7 +16166,7 @@
               <a:t> [3D model]. Free3D.</a:t>
             </a:r>
             <a:r>
-              <a:rPr lang="en-US" sz="400">
+              <a:rPr lang="en-US" sz="1000" dirty="0">
                 <a:solidFill>
                   <a:schemeClr val="dk1"/>
                 </a:solidFill>
@@ -16181,7 +16184,7 @@
               <a:t> </a:t>
             </a:r>
             <a:r>
-              <a:rPr lang="en-US" sz="400" u="sng">
+              <a:rPr lang="en-US" sz="1000" u="sng" dirty="0">
                 <a:solidFill>
                   <a:schemeClr val="hlink"/>
                 </a:solidFill>
@@ -16189,7 +16192,7 @@
               </a:rPr>
               <a:t>https://free3d.com/3d-model/diamond-3d-2855.html</a:t>
             </a:r>
-            <a:endParaRPr sz="400" u="sng">
+            <a:endParaRPr sz="1000" u="sng" dirty="0">
               <a:solidFill>
                 <a:schemeClr val="hlink"/>
               </a:solidFill>
@@ -16209,7 +16212,7 @@
               <a:buNone/>
             </a:pPr>
             <a:r>
-              <a:rPr lang="en-US" sz="400" b="1">
+              <a:rPr lang="en-US" sz="1000" b="1" dirty="0">
                 <a:solidFill>
                   <a:schemeClr val="dk1"/>
                 </a:solidFill>
@@ -16217,7 +16220,7 @@
               <a:t>SLTL Group</a:t>
             </a:r>
             <a:r>
-              <a:rPr lang="en-US" sz="400">
+              <a:rPr lang="en-US" sz="1000" dirty="0">
                 <a:solidFill>
                   <a:schemeClr val="dk1"/>
                 </a:solidFill>
@@ -16225,7 +16228,7 @@
               <a:t>. (n.d.). </a:t>
             </a:r>
             <a:r>
-              <a:rPr lang="en-US" sz="400" i="1">
+              <a:rPr lang="en-US" sz="1000" i="1" dirty="0">
                 <a:solidFill>
                   <a:schemeClr val="dk1"/>
                 </a:solidFill>
@@ -16233,7 +16236,7 @@
               <a:t>What is diamond processing?</a:t>
             </a:r>
             <a:r>
-              <a:rPr lang="en-US" sz="400">
+              <a:rPr lang="en-US" sz="1000" dirty="0">
                 <a:solidFill>
                   <a:schemeClr val="dk1"/>
                 </a:solidFill>
@@ -16241,7 +16244,7 @@
               <a:t> SLTL.</a:t>
             </a:r>
             <a:r>
-              <a:rPr lang="en-US" sz="400">
+              <a:rPr lang="en-US" sz="1000" dirty="0">
                 <a:solidFill>
                   <a:schemeClr val="dk1"/>
                 </a:solidFill>
@@ -16259,15 +16262,24 @@
               <a:t> </a:t>
             </a:r>
             <a:r>
-              <a:rPr lang="en-US" sz="400" u="sng">
+              <a:rPr lang="en-US" sz="1000" u="sng" dirty="0">
                 <a:solidFill>
                   <a:schemeClr val="hlink"/>
                 </a:solidFill>
                 <a:hlinkClick r:id="rId7"/>
               </a:rPr>
-              <a:t>https://www.sltl.com/what-is-diamond-processing/?srsltid=AfmBOorHbz9801OMMlAYemqO4Mb-vViZGohuBv6PwcDWCEYIt_GIQ8pi</a:t>
+              <a:t>https://www.sltl.com/what-is-diamond-processing/?srsltid</a:t>
             </a:r>
-            <a:endParaRPr sz="400" i="1">
+            <a:r>
+              <a:rPr lang="en-US" sz="400" u="sng" dirty="0">
+                <a:solidFill>
+                  <a:schemeClr val="hlink"/>
+                </a:solidFill>
+                <a:hlinkClick r:id="rId7"/>
+              </a:rPr>
+              <a:t>=AfmBOorHbz9801OMMlAYemqO4Mb-vViZGohuBv6PwcDWCEYIt_GIQ8pi</a:t>
+            </a:r>
+            <a:endParaRPr sz="400" i="1" dirty="0">
               <a:solidFill>
                 <a:schemeClr val="dk1"/>
               </a:solidFill>
@@ -16630,7 +16642,7 @@
               <a:buNone/>
             </a:pPr>
             <a:r>
-              <a:rPr lang="en-US" sz="400" b="1">
+              <a:rPr lang="en-US" sz="400" b="1" dirty="0" err="1">
                 <a:solidFill>
                   <a:schemeClr val="dk1"/>
                 </a:solidFill>
@@ -16638,7 +16650,7 @@
               <a:t>DesertCart</a:t>
             </a:r>
             <a:r>
-              <a:rPr lang="en-US" sz="400">
+              <a:rPr lang="en-US" sz="400" dirty="0">
                 <a:solidFill>
                   <a:schemeClr val="dk1"/>
                 </a:solidFill>
@@ -16646,23 +16658,55 @@
               <a:t>. (n.d.). </a:t>
             </a:r>
             <a:r>
-              <a:rPr lang="en-US" sz="400" i="1">
+              <a:rPr lang="en-US" sz="400" i="1" dirty="0">
                 <a:solidFill>
                   <a:schemeClr val="dk1"/>
                 </a:solidFill>
               </a:rPr>
-              <a:t>Shining 3D Einstar handheld 3D scanner with detail-oriented enhancement</a:t>
+              <a:t>Shining 3D </a:t>
             </a:r>
             <a:r>
-              <a:rPr lang="en-US" sz="400">
+              <a:rPr lang="en-US" sz="400" i="1" dirty="0" err="1">
                 <a:solidFill>
                   <a:schemeClr val="dk1"/>
                 </a:solidFill>
               </a:rPr>
-              <a:t> [Product]. DesertCart.</a:t>
+              <a:t>Einstar</a:t>
             </a:r>
             <a:r>
-              <a:rPr lang="en-US" sz="400">
+              <a:rPr lang="en-US" sz="400" i="1" dirty="0">
+                <a:solidFill>
+                  <a:schemeClr val="dk1"/>
+                </a:solidFill>
+              </a:rPr>
+              <a:t> handheld 3D scanner with detail-oriented enhancement</a:t>
+            </a:r>
+            <a:r>
+              <a:rPr lang="en-US" sz="400" dirty="0">
+                <a:solidFill>
+                  <a:schemeClr val="dk1"/>
+                </a:solidFill>
+              </a:rPr>
+              <a:t> [Product]. </a:t>
+            </a:r>
+            <a:r>
+              <a:rPr lang="en-US" sz="400" dirty="0" err="1">
+                <a:solidFill>
+                  <a:schemeClr val="dk1"/>
+                </a:solidFill>
+              </a:rPr>
+              <a:t>DesertCart</a:t>
+            </a:r>
+            <a:r>
+              <a:rPr lang="en-US" sz="400" dirty="0">
+                <a:solidFill>
+                  <a:schemeClr val="dk1"/>
+                </a:solidFill>
+              </a:rPr>
+              <a:t>.</a:t>
+            </a:r>
+            <a:r>
+              <a:rPr lang="en-US" sz="400" dirty="0">
                 <a:solidFill>
                   <a:schemeClr val="dk1"/>
                 </a:solidFill>
@@ -16680,7 +16724,7 @@
               <a:t> </a:t>
             </a:r>
             <a:r>
-              <a:rPr lang="en-US" sz="400" u="sng">
+              <a:rPr lang="en-US" sz="400" u="sng" dirty="0">
                 <a:solidFill>
                   <a:schemeClr val="hlink"/>
                 </a:solidFill>
@@ -16689,14 +16733,14 @@
               <a:t>https://www.desertcart.in/products/490281036-shining-3d-einstar-handheld-3d-scanner-with-detail-oriented-enhancement</a:t>
             </a:r>
             <a:br>
-              <a:rPr lang="en-US" sz="400" u="sng">
+              <a:rPr lang="en-US" sz="400" u="sng" dirty="0">
                 <a:solidFill>
                   <a:schemeClr val="hlink"/>
                 </a:solidFill>
                 <a:hlinkClick r:id="rId6"/>
               </a:rPr>
             </a:br>
-            <a:endParaRPr sz="400" u="sng">
+            <a:endParaRPr sz="400" u="sng" dirty="0">
               <a:solidFill>
                 <a:schemeClr val="hlink"/>
               </a:solidFill>
@@ -16716,7 +16760,7 @@
               <a:buNone/>
             </a:pPr>
             <a:r>
-              <a:rPr lang="en-US" sz="400" b="1">
+              <a:rPr lang="en-US" sz="400" b="1" dirty="0" err="1">
                 <a:solidFill>
                   <a:schemeClr val="dk1"/>
                 </a:solidFill>
@@ -16724,7 +16768,7 @@
               <a:t>Tanotis</a:t>
             </a:r>
             <a:r>
-              <a:rPr lang="en-US" sz="400">
+              <a:rPr lang="en-US" sz="400" dirty="0">
                 <a:solidFill>
                   <a:schemeClr val="dk1"/>
                 </a:solidFill>
@@ -16732,23 +16776,63 @@
               <a:t>. (n.d.). </a:t>
             </a:r>
             <a:r>
-              <a:rPr lang="en-US" sz="400" i="1">
+              <a:rPr lang="en-US" sz="400" i="1" dirty="0" err="1">
                 <a:solidFill>
                   <a:schemeClr val="dk1"/>
                 </a:solidFill>
               </a:rPr>
-              <a:t>Afinia Einscan SP v2 3D scanner with turntable</a:t>
+              <a:t>Afinia</a:t>
             </a:r>
             <a:r>
-              <a:rPr lang="en-US" sz="400">
+              <a:rPr lang="en-US" sz="400" i="1" dirty="0">
                 <a:solidFill>
                   <a:schemeClr val="dk1"/>
                 </a:solidFill>
               </a:rPr>
-              <a:t> [Product]. Tanotis.</a:t>
+              <a:t> </a:t>
             </a:r>
             <a:r>
-              <a:rPr lang="en-US" sz="400">
+              <a:rPr lang="en-US" sz="400" i="1" dirty="0" err="1">
+                <a:solidFill>
+                  <a:schemeClr val="dk1"/>
+                </a:solidFill>
+              </a:rPr>
+              <a:t>Einscan</a:t>
+            </a:r>
+            <a:r>
+              <a:rPr lang="en-US" sz="400" i="1" dirty="0">
+                <a:solidFill>
+                  <a:schemeClr val="dk1"/>
+                </a:solidFill>
+              </a:rPr>
+              <a:t> SP v2 3D scanner with turntable</a:t>
+            </a:r>
+            <a:r>
+              <a:rPr lang="en-US" sz="400" dirty="0">
+                <a:solidFill>
+                  <a:schemeClr val="dk1"/>
+                </a:solidFill>
+              </a:rPr>
+              <a:t> [Product]. </a:t>
+            </a:r>
+            <a:r>
+              <a:rPr lang="en-US" sz="400" dirty="0" err="1">
+                <a:solidFill>
+                  <a:schemeClr val="dk1"/>
+                </a:solidFill>
+              </a:rPr>
+              <a:t>Tanotis</a:t>
+            </a:r>
+            <a:r>
+              <a:rPr lang="en-US" sz="400" dirty="0">
+                <a:solidFill>
+                  <a:schemeClr val="dk1"/>
+                </a:solidFill>
+              </a:rPr>
+              <a:t>.</a:t>
+            </a:r>
+            <a:r>
+              <a:rPr lang="en-US" sz="400" dirty="0">
                 <a:solidFill>
                   <a:schemeClr val="dk1"/>
                 </a:solidFill>
@@ -16766,7 +16850,7 @@
               <a:t> </a:t>
             </a:r>
             <a:r>
-              <a:rPr lang="en-US" sz="400" u="sng">
+              <a:rPr lang="en-US" sz="400" u="sng" dirty="0">
                 <a:solidFill>
                   <a:schemeClr val="hlink"/>
                 </a:solidFill>
@@ -16775,14 +16859,14 @@
               <a:t>https://www.tanotis.com/products/afinia-einscan-sp-v2-3d-scanner-with-turntable?srsltid=AfmBOorEgV0iKuS6XC0BaTnXuSLetztvha3OFbSigEQrjNZjTNgCuAWbgDA</a:t>
             </a:r>
             <a:br>
-              <a:rPr lang="en-US" sz="400" u="sng">
+              <a:rPr lang="en-US" sz="400" u="sng" dirty="0">
                 <a:solidFill>
                   <a:schemeClr val="hlink"/>
                 </a:solidFill>
                 <a:hlinkClick r:id="rId7"/>
               </a:rPr>
             </a:br>
-            <a:endParaRPr sz="400" u="sng">
+            <a:endParaRPr sz="400" u="sng" dirty="0">
               <a:solidFill>
                 <a:schemeClr val="hlink"/>
               </a:solidFill>
@@ -16802,7 +16886,7 @@
               <a:buNone/>
             </a:pPr>
             <a:r>
-              <a:rPr lang="en-US" sz="400" b="1">
+              <a:rPr lang="en-US" sz="400" b="1" dirty="0" err="1">
                 <a:solidFill>
                   <a:schemeClr val="dk1"/>
                 </a:solidFill>
@@ -16810,7 +16894,7 @@
               <a:t>IndustryBuying</a:t>
             </a:r>
             <a:r>
-              <a:rPr lang="en-US" sz="400">
+              <a:rPr lang="en-US" sz="400" dirty="0">
                 <a:solidFill>
                   <a:schemeClr val="dk1"/>
                 </a:solidFill>
@@ -16818,23 +16902,47 @@
               <a:t>. (n.d.). </a:t>
             </a:r>
             <a:r>
-              <a:rPr lang="en-US" sz="400" i="1">
+              <a:rPr lang="en-US" sz="400" i="1" dirty="0" err="1">
                 <a:solidFill>
                   <a:schemeClr val="dk1"/>
                 </a:solidFill>
               </a:rPr>
-              <a:t>Insize 3D printers</a:t>
+              <a:t>Insize</a:t>
             </a:r>
             <a:r>
-              <a:rPr lang="en-US" sz="400">
+              <a:rPr lang="en-US" sz="400" i="1" dirty="0">
                 <a:solidFill>
                   <a:schemeClr val="dk1"/>
                 </a:solidFill>
               </a:rPr>
-              <a:t> [Product]. IndustryBuying.</a:t>
+              <a:t> 3D printers</a:t>
             </a:r>
             <a:r>
-              <a:rPr lang="en-US" sz="400">
+              <a:rPr lang="en-US" sz="400" dirty="0">
+                <a:solidFill>
+                  <a:schemeClr val="dk1"/>
+                </a:solidFill>
+              </a:rPr>
+              <a:t> [Product]. </a:t>
+            </a:r>
+            <a:r>
+              <a:rPr lang="en-US" sz="400" dirty="0" err="1">
+                <a:solidFill>
+                  <a:schemeClr val="dk1"/>
+                </a:solidFill>
+              </a:rPr>
+              <a:t>IndustryBuying</a:t>
+            </a:r>
+            <a:r>
+              <a:rPr lang="en-US" sz="400" dirty="0">
+                <a:solidFill>
+                  <a:schemeClr val="dk1"/>
+                </a:solidFill>
+              </a:rPr>
+              <a:t>.</a:t>
+            </a:r>
+            <a:r>
+              <a:rPr lang="en-US" sz="400" dirty="0">
                 <a:solidFill>
                   <a:schemeClr val="dk1"/>
                 </a:solidFill>
@@ -16852,7 +16960,7 @@
               <a:t> </a:t>
             </a:r>
             <a:r>
-              <a:rPr lang="en-US" sz="400" u="sng">
+              <a:rPr lang="en-US" sz="400" u="sng" dirty="0">
                 <a:solidFill>
                   <a:schemeClr val="hlink"/>
                 </a:solidFill>
@@ -16860,7 +16968,7 @@
               </a:rPr>
               <a:t>https://www.industrybuying.com/3d-printers-insize-IND.3DP.632953547</a:t>
             </a:r>
-            <a:endParaRPr sz="400" u="sng">
+            <a:endParaRPr sz="400" u="sng" dirty="0">
               <a:solidFill>
                 <a:schemeClr val="hlink"/>
               </a:solidFill>
@@ -16879,7 +16987,7 @@
               </a:spcAft>
               <a:buNone/>
             </a:pPr>
-            <a:endParaRPr sz="400" i="1">
+            <a:endParaRPr sz="400" i="1" dirty="0">
               <a:solidFill>
                 <a:schemeClr val="dk1"/>
               </a:solidFill>
@@ -17013,7 +17121,7 @@
               <a:buChar char="•"/>
             </a:pPr>
             <a:r>
-              <a:rPr lang="en-US" sz="2200">
+              <a:rPr lang="en-US" sz="2200" dirty="0">
                 <a:latin typeface="Helvetica Neue"/>
                 <a:ea typeface="Helvetica Neue"/>
                 <a:cs typeface="Helvetica Neue"/>
@@ -17022,7 +17130,7 @@
               <a:t>Previous works explored </a:t>
             </a:r>
             <a:r>
-              <a:rPr lang="en-US" sz="2200" b="1">
+              <a:rPr lang="en-US" sz="2200" b="1" dirty="0">
                 <a:latin typeface="Helvetica Neue"/>
                 <a:ea typeface="Helvetica Neue"/>
                 <a:cs typeface="Helvetica Neue"/>
@@ -17031,7 +17139,7 @@
               <a:t>multi-view 3D reconstruction</a:t>
             </a:r>
             <a:r>
-              <a:rPr lang="en-US" sz="2200">
+              <a:rPr lang="en-US" sz="2200" dirty="0">
                 <a:latin typeface="Helvetica Neue"/>
                 <a:ea typeface="Helvetica Neue"/>
                 <a:cs typeface="Helvetica Neue"/>
@@ -17040,14 +17148,63 @@
               <a:t> using image silhouettes.</a:t>
             </a:r>
             <a:br>
-              <a:rPr lang="en-US" sz="2200">
+              <a:rPr lang="en-US" sz="2200" dirty="0">
                 <a:latin typeface="Helvetica Neue"/>
                 <a:ea typeface="Helvetica Neue"/>
                 <a:cs typeface="Helvetica Neue"/>
                 <a:sym typeface="Helvetica Neue"/>
               </a:rPr>
             </a:br>
-            <a:endParaRPr sz="2200">
+            <a:endParaRPr sz="2200" dirty="0">
+              <a:latin typeface="Helvetica Neue"/>
+              <a:ea typeface="Helvetica Neue"/>
+              <a:cs typeface="Helvetica Neue"/>
+              <a:sym typeface="Helvetica Neue"/>
+            </a:endParaRPr>
+          </a:p>
+          <a:p>
+            <a:pPr marL="228600" lvl="0" indent="-215900">
+              <a:lnSpc>
+                <a:spcPct val="115000"/>
+              </a:lnSpc>
+              <a:spcBef>
+                <a:spcPts val="0"/>
+              </a:spcBef>
+              <a:buSzPts val="2200"/>
+              <a:buFont typeface="Helvetica Neue"/>
+              <a:buChar char="•"/>
+            </a:pPr>
+            <a:r>
+              <a:rPr lang="en-US" sz="2000" dirty="0" err="1"/>
+              <a:t>Mamand</a:t>
+            </a:r>
+            <a:r>
+              <a:rPr lang="en-US" sz="2000" dirty="0"/>
+              <a:t>, S. S., &amp; Abdulla, A. I. (2024). 2D to 3D image conversion algorithms. </a:t>
+            </a:r>
+            <a:r>
+              <a:rPr lang="en-US" sz="2000" i="1" dirty="0"/>
+              <a:t>ITM Web of Conferences, 7</a:t>
+            </a:r>
+            <a:r>
+              <a:rPr lang="en-US" sz="2000" dirty="0"/>
+              <a:t>, 01010. </a:t>
+            </a:r>
+            <a:r>
+              <a:rPr lang="en-US" sz="2000" dirty="0">
+                <a:hlinkClick r:id="rId3"/>
+              </a:rPr>
+              <a:t>https://www.itm-conferences.org/articles/itmconf/pdf/2024/07/itmconf_icacs2024_01010.pdf</a:t>
+            </a:r>
+            <a:br>
+              <a:rPr lang="en-US" sz="2200" dirty="0">
+                <a:latin typeface="Helvetica Neue"/>
+                <a:ea typeface="Helvetica Neue"/>
+                <a:cs typeface="Helvetica Neue"/>
+                <a:sym typeface="Helvetica Neue"/>
+              </a:rPr>
+            </a:br>
+            <a:endParaRPr sz="2200" dirty="0">
               <a:latin typeface="Helvetica Neue"/>
               <a:ea typeface="Helvetica Neue"/>
               <a:cs typeface="Helvetica Neue"/>
@@ -17070,46 +17227,7 @@
               <a:buChar char="•"/>
             </a:pPr>
             <a:r>
-              <a:rPr lang="en-US" sz="2200">
-                <a:latin typeface="Helvetica Neue"/>
-                <a:ea typeface="Helvetica Neue"/>
-                <a:cs typeface="Helvetica Neue"/>
-                <a:sym typeface="Helvetica Neue"/>
-              </a:rPr>
-              <a:t>ITM Conferences (2024) – Focused on voxel carving from silhouette images.</a:t>
-            </a:r>
-            <a:br>
-              <a:rPr lang="en-US" sz="2200">
-                <a:latin typeface="Helvetica Neue"/>
-                <a:ea typeface="Helvetica Neue"/>
-                <a:cs typeface="Helvetica Neue"/>
-                <a:sym typeface="Helvetica Neue"/>
-              </a:rPr>
-            </a:br>
-            <a:endParaRPr sz="2200">
-              <a:latin typeface="Helvetica Neue"/>
-              <a:ea typeface="Helvetica Neue"/>
-              <a:cs typeface="Helvetica Neue"/>
-              <a:sym typeface="Helvetica Neue"/>
-            </a:endParaRPr>
-          </a:p>
-          <a:p>
-            <a:pPr marL="228600" lvl="0" indent="-215900" algn="l" rtl="0">
-              <a:lnSpc>
-                <a:spcPct val="115000"/>
-              </a:lnSpc>
-              <a:spcBef>
-                <a:spcPts val="0"/>
-              </a:spcBef>
-              <a:spcAft>
-                <a:spcPts val="0"/>
-              </a:spcAft>
-              <a:buSzPts val="2200"/>
-              <a:buFont typeface="Helvetica Neue"/>
-              <a:buChar char="•"/>
-            </a:pPr>
-            <a:r>
-              <a:rPr lang="en-US" sz="2200">
+              <a:rPr lang="en-US" sz="2200" dirty="0">
                 <a:latin typeface="Helvetica Neue"/>
                 <a:ea typeface="Helvetica Neue"/>
                 <a:cs typeface="Helvetica Neue"/>
@@ -17118,7 +17236,7 @@
               <a:t>Our approach adapts these principles to </a:t>
             </a:r>
             <a:r>
-              <a:rPr lang="en-US" sz="2200" b="1">
+              <a:rPr lang="en-US" sz="2200" b="1" dirty="0">
                 <a:latin typeface="Helvetica Neue"/>
                 <a:ea typeface="Helvetica Neue"/>
                 <a:cs typeface="Helvetica Neue"/>
@@ -17127,7 +17245,7 @@
               <a:t>diamond images</a:t>
             </a:r>
             <a:r>
-              <a:rPr lang="en-US" sz="2200">
+              <a:rPr lang="en-US" sz="2200" dirty="0">
                 <a:latin typeface="Helvetica Neue"/>
                 <a:ea typeface="Helvetica Neue"/>
                 <a:cs typeface="Helvetica Neue"/>
@@ -17135,7 +17253,7 @@
               </a:rPr>
               <a:t> for accurate 3D shape recovery.</a:t>
             </a:r>
-            <a:endParaRPr sz="2200">
+            <a:endParaRPr sz="2200" dirty="0">
               <a:latin typeface="Helvetica Neue"/>
               <a:ea typeface="Helvetica Neue"/>
               <a:cs typeface="Helvetica Neue"/>
@@ -17155,7 +17273,7 @@
               </a:spcAft>
               <a:buNone/>
             </a:pPr>
-            <a:endParaRPr sz="2200"/>
+            <a:endParaRPr sz="2200" dirty="0"/>
           </a:p>
           <a:p>
             <a:pPr marL="228600" lvl="0" indent="-76200" algn="l" rtl="0">
@@ -17175,7 +17293,7 @@
               <a:buFont typeface="Helvetica Neue Light"/>
               <a:buNone/>
             </a:pPr>
-            <a:endParaRPr sz="2200"/>
+            <a:endParaRPr sz="2200" dirty="0"/>
           </a:p>
           <a:p>
             <a:pPr marL="228600" lvl="0" indent="-76200" algn="l" rtl="0">
@@ -17195,7 +17313,7 @@
               <a:buFont typeface="Helvetica Neue Light"/>
               <a:buNone/>
             </a:pPr>
-            <a:endParaRPr sz="2200"/>
+            <a:endParaRPr sz="2200" dirty="0"/>
           </a:p>
         </p:txBody>
       </p:sp>
@@ -17315,7 +17433,7 @@
           <p:nvPr/>
         </p:nvPicPr>
         <p:blipFill>
-          <a:blip r:embed="rId3">
+          <a:blip r:embed="rId4">
             <a:alphaModFix/>
           </a:blip>
           <a:stretch>
@@ -17324,8 +17442,8 @@
         </p:blipFill>
         <p:spPr>
           <a:xfrm>
-            <a:off x="4361899" y="3429000"/>
-            <a:ext cx="4289501" cy="2992350"/>
+            <a:off x="4361900" y="4258848"/>
+            <a:ext cx="3316556" cy="2162501"/>
           </a:xfrm>
           <a:prstGeom prst="rect">
             <a:avLst/>
@@ -18380,7 +18498,7 @@
         </p:spPr>
         <p:txBody>
           <a:bodyPr spcFirstLastPara="1" wrap="square" lIns="91425" tIns="45700" rIns="91425" bIns="45700" anchor="t" anchorCtr="0">
-            <a:normAutofit fontScale="85000" lnSpcReduction="10000"/>
+            <a:normAutofit fontScale="92500" lnSpcReduction="10000"/>
           </a:bodyPr>
           <a:lstStyle/>
           <a:p>

</xml_diff>